<commit_message>
data-eng: 1~8일차 시간 블록별 강의 슬라이드 33덱 335장 (deckgen 생성, PDF·PPTX)
Co-Authored-By: Claude Fable 5.1 <noreply@anthropic.com>
</commit_message>
<xml_diff>
--- a/data-eng/decks/w1d4s1.pptx
+++ b/data-eng/decks/w1d4s1.pptx
@@ -14179,6 +14179,191 @@
             </a:avLst>
           </a:prstGeom>
           <a:solidFill>
+            <a:srgbClr val="0D2B5E"/>
+          </a:solidFill>
+          <a:ln w="9525">
+            <a:solidFill>
+              <a:srgbClr val="0D2B5E"/>
+            </a:solidFill>
+          </a:ln>
+          <a:effectLst/>
+        </p:spPr>
+        <p:txBody>
+          <a:bodyPr rtlCol="0" anchor="ctr" wrap="square"/>
+          <a:lstStyle/>
+          <a:p>
+            <a:pPr algn="ctr"/>
+          </a:p>
+        </p:txBody>
+      </p:sp>
+      <p:sp>
+        <p:nvSpPr>
+          <p:cNvPr id="13" name="Rectangle 12"/>
+          <p:cNvSpPr/>
+          <p:nvPr/>
+        </p:nvSpPr>
+        <p:spPr>
+          <a:xfrm>
+            <a:off x="6604000" y="3429000"/>
+            <a:ext cx="5080000" cy="47625"/>
+          </a:xfrm>
+          <a:prstGeom prst="rect">
+            <a:avLst/>
+          </a:prstGeom>
+          <a:solidFill>
+            <a:srgbClr val="1E5BC6"/>
+          </a:solidFill>
+          <a:ln>
+            <a:noFill/>
+          </a:ln>
+          <a:effectLst/>
+        </p:spPr>
+        <p:txBody>
+          <a:bodyPr rtlCol="0" anchor="ctr" wrap="square"/>
+          <a:lstStyle/>
+          <a:p>
+            <a:pPr algn="ctr"/>
+          </a:p>
+        </p:txBody>
+      </p:sp>
+      <p:sp>
+        <p:nvSpPr>
+          <p:cNvPr id="14" name="TextBox 13"/>
+          <p:cNvSpPr txBox="1"/>
+          <p:nvPr/>
+        </p:nvSpPr>
+        <p:spPr>
+          <a:xfrm>
+            <a:off x="10826750" y="3638550"/>
+            <a:ext cx="590550" cy="400050"/>
+          </a:xfrm>
+          <a:prstGeom prst="rect">
+            <a:avLst/>
+          </a:prstGeom>
+          <a:noFill/>
+        </p:spPr>
+        <p:txBody>
+          <a:bodyPr wrap="square" lIns="0" rIns="0" tIns="0" bIns="0" anchor="t">
+            <a:spAutoFit/>
+          </a:bodyPr>
+          <a:lstStyle/>
+          <a:p>
+            <a:pPr algn="r">
+              <a:lnSpc>
+                <a:spcPct val="100000"/>
+              </a:lnSpc>
+            </a:pPr>
+            <a:r>
+              <a:rPr sz="2550" b="1">
+                <a:solidFill>
+                  <a:srgbClr val="3B4B7C"/>
+                </a:solidFill>
+                <a:latin typeface="Pretendard"/>
+                <a:ea typeface="Pretendard"/>
+                <a:cs typeface="Pretendard"/>
+              </a:rPr>
+              <a:t>02</a:t>
+            </a:r>
+          </a:p>
+        </p:txBody>
+      </p:sp>
+      <p:sp>
+        <p:nvSpPr>
+          <p:cNvPr id="15" name="TextBox 14"/>
+          <p:cNvSpPr txBox="1"/>
+          <p:nvPr/>
+        </p:nvSpPr>
+        <p:spPr>
+          <a:xfrm>
+            <a:off x="6927850" y="3752850"/>
+            <a:ext cx="4432300" cy="1828800"/>
+          </a:xfrm>
+          <a:prstGeom prst="rect">
+            <a:avLst/>
+          </a:prstGeom>
+          <a:noFill/>
+        </p:spPr>
+        <p:txBody>
+          <a:bodyPr wrap="square" lIns="0" rIns="0" tIns="0" bIns="0" anchor="ctr">
+            <a:spAutoFit/>
+          </a:bodyPr>
+          <a:lstStyle/>
+          <a:p>
+            <a:pPr>
+              <a:lnSpc>
+                <a:spcPct val="115000"/>
+              </a:lnSpc>
+            </a:pPr>
+            <a:r>
+              <a:rPr sz="2400" b="1">
+                <a:solidFill>
+                  <a:srgbClr val="FFFFFF"/>
+                </a:solidFill>
+                <a:latin typeface="Pretendard"/>
+                <a:ea typeface="Pretendard"/>
+                <a:cs typeface="Pretendard"/>
+              </a:rPr>
+              <a:t>python:3.12-slim · 약 130MB</a:t>
+            </a:r>
+          </a:p>
+          <a:p>
+            <a:pPr>
+              <a:lnSpc>
+                <a:spcPct val="146000"/>
+              </a:lnSpc>
+              <a:spcBef>
+                <a:spcPts val="1050"/>
+              </a:spcBef>
+            </a:pPr>
+            <a:r>
+              <a:rPr sz="2250" b="0">
+                <a:solidFill>
+                  <a:srgbClr val="D9E2F0"/>
+                </a:solidFill>
+                <a:latin typeface="Pretendard"/>
+                <a:ea typeface="Pretendard"/>
+                <a:cs typeface="Pretendard"/>
+              </a:rPr>
+              <a:t>실행에 필요한 최소한</a:t>
+            </a:r>
+          </a:p>
+          <a:p>
+            <a:pPr>
+              <a:lnSpc>
+                <a:spcPct val="146000"/>
+              </a:lnSpc>
+            </a:pPr>
+            <a:r>
+              <a:rPr sz="2250" b="0">
+                <a:solidFill>
+                  <a:srgbClr val="D9E2F0"/>
+                </a:solidFill>
+                <a:latin typeface="Pretendard"/>
+                <a:ea typeface="Pretendard"/>
+                <a:cs typeface="Pretendard"/>
+              </a:rPr>
+              <a:t>이번 과정의 기본값</a:t>
+            </a:r>
+          </a:p>
+        </p:txBody>
+      </p:sp>
+      <p:sp>
+        <p:nvSpPr>
+          <p:cNvPr id="16" name="Rounded Rectangle 15"/>
+          <p:cNvSpPr/>
+          <p:nvPr/>
+        </p:nvSpPr>
+        <p:spPr>
+          <a:xfrm>
+            <a:off x="12065000" y="3429000"/>
+            <a:ext cx="5080000" cy="2476500"/>
+          </a:xfrm>
+          <a:prstGeom prst="roundRect">
+            <a:avLst>
+              <a:gd name="adj" fmla="val 1923"/>
+            </a:avLst>
+          </a:prstGeom>
+          <a:solidFill>
             <a:srgbClr val="FAFBFD"/>
           </a:solidFill>
           <a:ln w="9525">
@@ -14198,13 +14383,13 @@
       </p:sp>
       <p:sp>
         <p:nvSpPr>
-          <p:cNvPr id="13" name="Rectangle 12"/>
-          <p:cNvSpPr/>
-          <p:nvPr/>
-        </p:nvSpPr>
-        <p:spPr>
-          <a:xfrm>
-            <a:off x="6604000" y="3429000"/>
+          <p:cNvPr id="17" name="Rectangle 16"/>
+          <p:cNvSpPr/>
+          <p:nvPr/>
+        </p:nvSpPr>
+        <p:spPr>
+          <a:xfrm>
+            <a:off x="12065000" y="3429000"/>
             <a:ext cx="5080000" cy="47625"/>
           </a:xfrm>
           <a:prstGeom prst="rect">
@@ -14228,13 +14413,13 @@
       </p:sp>
       <p:sp>
         <p:nvSpPr>
-          <p:cNvPr id="14" name="TextBox 13"/>
-          <p:cNvSpPr txBox="1"/>
-          <p:nvPr/>
-        </p:nvSpPr>
-        <p:spPr>
-          <a:xfrm>
-            <a:off x="10826750" y="3638550"/>
+          <p:cNvPr id="18" name="TextBox 17"/>
+          <p:cNvSpPr txBox="1"/>
+          <p:nvPr/>
+        </p:nvSpPr>
+        <p:spPr>
+          <a:xfrm>
+            <a:off x="16287750" y="3638550"/>
             <a:ext cx="590550" cy="400050"/>
           </a:xfrm>
           <a:prstGeom prst="rect">
@@ -14262,20 +14447,20 @@
                 <a:ea typeface="Pretendard"/>
                 <a:cs typeface="Pretendard"/>
               </a:rPr>
-              <a:t>02</a:t>
-            </a:r>
-          </a:p>
-        </p:txBody>
-      </p:sp>
-      <p:sp>
-        <p:nvSpPr>
-          <p:cNvPr id="15" name="TextBox 14"/>
-          <p:cNvSpPr txBox="1"/>
-          <p:nvPr/>
-        </p:nvSpPr>
-        <p:spPr>
-          <a:xfrm>
-            <a:off x="6927850" y="3752850"/>
+              <a:t>03</a:t>
+            </a:r>
+          </a:p>
+        </p:txBody>
+      </p:sp>
+      <p:sp>
+        <p:nvSpPr>
+          <p:cNvPr id="19" name="TextBox 18"/>
+          <p:cNvSpPr txBox="1"/>
+          <p:nvPr/>
+        </p:nvSpPr>
+        <p:spPr>
+          <a:xfrm>
+            <a:off x="12388850" y="3752850"/>
             <a:ext cx="4432300" cy="1828800"/>
           </a:xfrm>
           <a:prstGeom prst="rect">
@@ -14303,7 +14488,7 @@
                 <a:ea typeface="Pretendard"/>
                 <a:cs typeface="Pretendard"/>
               </a:rPr>
-              <a:t>python:3.12-slim · 약 130MB</a:t>
+              <a:t>python:3.12-alpine · 약 50MB</a:t>
             </a:r>
           </a:p>
           <a:p>
@@ -14324,7 +14509,7 @@
                 <a:ea typeface="Pretendard"/>
                 <a:cs typeface="Pretendard"/>
               </a:rPr>
-              <a:t>실행에 필요한 최소한</a:t>
+              <a:t>가장 작지만 C 라이브러리가 다르다</a:t>
             </a:r>
           </a:p>
           <a:p>
@@ -14337,191 +14522,6 @@
               <a:rPr sz="2250" b="0">
                 <a:solidFill>
                   <a:srgbClr val="3D3D3D"/>
-                </a:solidFill>
-                <a:latin typeface="Pretendard"/>
-                <a:ea typeface="Pretendard"/>
-                <a:cs typeface="Pretendard"/>
-              </a:rPr>
-              <a:t>이번 과정의 기본값</a:t>
-            </a:r>
-          </a:p>
-        </p:txBody>
-      </p:sp>
-      <p:sp>
-        <p:nvSpPr>
-          <p:cNvPr id="16" name="Rounded Rectangle 15"/>
-          <p:cNvSpPr/>
-          <p:nvPr/>
-        </p:nvSpPr>
-        <p:spPr>
-          <a:xfrm>
-            <a:off x="12065000" y="3429000"/>
-            <a:ext cx="5080000" cy="2476500"/>
-          </a:xfrm>
-          <a:prstGeom prst="roundRect">
-            <a:avLst>
-              <a:gd name="adj" fmla="val 1923"/>
-            </a:avLst>
-          </a:prstGeom>
-          <a:solidFill>
-            <a:srgbClr val="0D2B5E"/>
-          </a:solidFill>
-          <a:ln w="9525">
-            <a:solidFill>
-              <a:srgbClr val="0D2B5E"/>
-            </a:solidFill>
-          </a:ln>
-          <a:effectLst/>
-        </p:spPr>
-        <p:txBody>
-          <a:bodyPr rtlCol="0" anchor="ctr" wrap="square"/>
-          <a:lstStyle/>
-          <a:p>
-            <a:pPr algn="ctr"/>
-          </a:p>
-        </p:txBody>
-      </p:sp>
-      <p:sp>
-        <p:nvSpPr>
-          <p:cNvPr id="17" name="Rectangle 16"/>
-          <p:cNvSpPr/>
-          <p:nvPr/>
-        </p:nvSpPr>
-        <p:spPr>
-          <a:xfrm>
-            <a:off x="12065000" y="3429000"/>
-            <a:ext cx="5080000" cy="47625"/>
-          </a:xfrm>
-          <a:prstGeom prst="rect">
-            <a:avLst/>
-          </a:prstGeom>
-          <a:solidFill>
-            <a:srgbClr val="1E5BC6"/>
-          </a:solidFill>
-          <a:ln>
-            <a:noFill/>
-          </a:ln>
-          <a:effectLst/>
-        </p:spPr>
-        <p:txBody>
-          <a:bodyPr rtlCol="0" anchor="ctr" wrap="square"/>
-          <a:lstStyle/>
-          <a:p>
-            <a:pPr algn="ctr"/>
-          </a:p>
-        </p:txBody>
-      </p:sp>
-      <p:sp>
-        <p:nvSpPr>
-          <p:cNvPr id="18" name="TextBox 17"/>
-          <p:cNvSpPr txBox="1"/>
-          <p:nvPr/>
-        </p:nvSpPr>
-        <p:spPr>
-          <a:xfrm>
-            <a:off x="16287750" y="3638550"/>
-            <a:ext cx="590550" cy="400050"/>
-          </a:xfrm>
-          <a:prstGeom prst="rect">
-            <a:avLst/>
-          </a:prstGeom>
-          <a:noFill/>
-        </p:spPr>
-        <p:txBody>
-          <a:bodyPr wrap="square" lIns="0" rIns="0" tIns="0" bIns="0" anchor="t">
-            <a:spAutoFit/>
-          </a:bodyPr>
-          <a:lstStyle/>
-          <a:p>
-            <a:pPr algn="r">
-              <a:lnSpc>
-                <a:spcPct val="100000"/>
-              </a:lnSpc>
-            </a:pPr>
-            <a:r>
-              <a:rPr sz="2550" b="1">
-                <a:solidFill>
-                  <a:srgbClr val="3B4B7C"/>
-                </a:solidFill>
-                <a:latin typeface="Pretendard"/>
-                <a:ea typeface="Pretendard"/>
-                <a:cs typeface="Pretendard"/>
-              </a:rPr>
-              <a:t>03</a:t>
-            </a:r>
-          </a:p>
-        </p:txBody>
-      </p:sp>
-      <p:sp>
-        <p:nvSpPr>
-          <p:cNvPr id="19" name="TextBox 18"/>
-          <p:cNvSpPr txBox="1"/>
-          <p:nvPr/>
-        </p:nvSpPr>
-        <p:spPr>
-          <a:xfrm>
-            <a:off x="12388850" y="3752850"/>
-            <a:ext cx="4432300" cy="1828800"/>
-          </a:xfrm>
-          <a:prstGeom prst="rect">
-            <a:avLst/>
-          </a:prstGeom>
-          <a:noFill/>
-        </p:spPr>
-        <p:txBody>
-          <a:bodyPr wrap="square" lIns="0" rIns="0" tIns="0" bIns="0" anchor="ctr">
-            <a:spAutoFit/>
-          </a:bodyPr>
-          <a:lstStyle/>
-          <a:p>
-            <a:pPr>
-              <a:lnSpc>
-                <a:spcPct val="115000"/>
-              </a:lnSpc>
-            </a:pPr>
-            <a:r>
-              <a:rPr sz="2400" b="1">
-                <a:solidFill>
-                  <a:srgbClr val="FFFFFF"/>
-                </a:solidFill>
-                <a:latin typeface="Pretendard"/>
-                <a:ea typeface="Pretendard"/>
-                <a:cs typeface="Pretendard"/>
-              </a:rPr>
-              <a:t>python:3.12-alpine · 약 50MB</a:t>
-            </a:r>
-          </a:p>
-          <a:p>
-            <a:pPr>
-              <a:lnSpc>
-                <a:spcPct val="146000"/>
-              </a:lnSpc>
-              <a:spcBef>
-                <a:spcPts val="1050"/>
-              </a:spcBef>
-            </a:pPr>
-            <a:r>
-              <a:rPr sz="2250" b="0">
-                <a:solidFill>
-                  <a:srgbClr val="D9E2F0"/>
-                </a:solidFill>
-                <a:latin typeface="Pretendard"/>
-                <a:ea typeface="Pretendard"/>
-                <a:cs typeface="Pretendard"/>
-              </a:rPr>
-              <a:t>가장 작지만 C 라이브러리가 다르다</a:t>
-            </a:r>
-          </a:p>
-          <a:p>
-            <a:pPr>
-              <a:lnSpc>
-                <a:spcPct val="146000"/>
-              </a:lnSpc>
-            </a:pPr>
-            <a:r>
-              <a:rPr sz="2250" b="0">
-                <a:solidFill>
-                  <a:srgbClr val="D9E2F0"/>
                 </a:solidFill>
                 <a:latin typeface="Pretendard"/>
                 <a:ea typeface="Pretendard"/>

</xml_diff>